<commit_message>
M16: regenerate northgate-staffing under the wave's knobs (baseline + noise; the exemplar)
Wholesale regen through the live airlock (claude-opus-4-8[1m], xhigh). The
exemplar finally carries the wave's fixes: business_calendar (0 weekend
meetings, the cited Saturday 2016-05-28 and 2023-07-04 sessions gone),
book_is_sample (overview no longer claims the whole book), style_specs (12
specs) + voice_diversify, and organizational noise (13 derived: copies,
drafts, diverging version chains, a misfile, a dead template, empty dirs,
decorated filenames). Validates clean (27 rules, NOISE-01/CAL-01 run, 0
errors); self-scores 100%; byte-pin re-derives; org-tier green.
</commit_message>
<xml_diff>
--- a/companies/northgate-staffing/Engagements/Coleman Ltd/2016.04.27 - Briefing Deck - Coleman Ltd.pptx
+++ b/companies/northgate-staffing/Engagements/Coleman Ltd/2016.04.27 - Briefing Deck - Coleman Ltd.pptx
@@ -10,7 +10,6 @@
     <p:sldId id="258" r:id="rId9"/>
     <p:sldId id="259" r:id="rId10"/>
     <p:sldId id="260" r:id="rId11"/>
-    <p:sldId id="261" r:id="rId12"/>
   </p:sldIdLst>
   <p:sldSz cx="9144000" cy="6858000" type="screen4x3"/>
   <p:notesSz cx="6858000" cy="9144000"/>
@@ -3114,7 +3113,7 @@
                   <a:srgbClr val="1E4D2B"/>
                 </a:solidFill>
               </a:rPr>
-              <a:t>Vice President of Engineering Search: Coleman Ltd</a:t>
+              <a:t>Vice President of Engineering — Retained Search</a:t>
             </a:r>
           </a:p>
         </p:txBody>
@@ -3147,25 +3146,25 @@
           <a:p>
             <a:pPr lvl="1"/>
             <a:r>
-              <a:t>Engagement commenced March 6, 2016</a:t>
+              <a:t>Sponsor: Michael Martin, Chief Operating Officer</a:t>
             </a:r>
           </a:p>
           <a:p>
             <a:pPr lvl="1"/>
             <a:r>
-              <a:t>Prepared for Michael Martin, Chief Operating Officer</a:t>
+              <a:t>Engagement opened March 6, 2016</a:t>
             </a:r>
           </a:p>
           <a:p>
             <a:pPr lvl="1"/>
             <a:r>
-              <a:t>Prepared by Jeffrey Patterson, Research Consultant</a:t>
+              <a:t>A retained assignment, run to a written specification rather than a contingency scramble</a:t>
             </a:r>
           </a:p>
           <a:p>
             <a:pPr lvl="1"/>
             <a:r>
-              <a:t>Confidential. Candidates are identified by current role only.</a:t>
+              <a:t>Prepared by your Northgate search team for this progress review</a:t>
             </a:r>
           </a:p>
         </p:txBody>
@@ -3209,7 +3208,7 @@
                   <a:srgbClr val="1E4D2B"/>
                 </a:solidFill>
               </a:rPr>
-              <a:t>Where the Search Stands</a:t>
+              <a:t>The mandate</a:t>
             </a:r>
           </a:p>
         </p:txBody>
@@ -3231,31 +3230,31 @@
           <a:p>
             <a:pPr lvl="1"/>
             <a:r>
-              <a:t>Specification agreed and signed. We are sourcing against it, not against the job description it started as.</a:t>
+              <a:t>A Vice President of Engineering to lead the engineering function at Coleman Ltd.</a:t>
             </a:r>
           </a:p>
           <a:p>
             <a:pPr lvl="1"/>
             <a:r>
-              <a:t>Target company list closed at the companies we can approach and will approach.</a:t>
+              <a:t>A senior operating role, reporting into the leadership team and owning the people in it.</a:t>
             </a:r>
           </a:p>
           <a:p>
             <a:pPr lvl="1"/>
             <a:r>
-              <a:t>Market map complete. Long list built and being worked.</a:t>
+              <a:t>We are looking for an operator who has scaled a function, not a first-time leader.</a:t>
             </a:r>
           </a:p>
           <a:p>
             <a:pPr lvl="1"/>
             <a:r>
-              <a:t>First conversations underway. No slate yet, and none should be expected at this point in the work.</a:t>
+              <a:t>Someone the current team will follow, not only someone the board will approve.</a:t>
             </a:r>
           </a:p>
           <a:p>
             <a:pPr lvl="1"/>
             <a:r>
-              <a:t>On plan.</a:t>
+              <a:t>The written specification agreed at kickoff governs the search from here, and we hold ourselves to it.</a:t>
             </a:r>
           </a:p>
         </p:txBody>
@@ -3299,7 +3298,7 @@
                   <a:srgbClr val="1E4D2B"/>
                 </a:solidFill>
               </a:rPr>
-              <a:t>What the Market Looks Like</a:t>
+              <a:t>How we are running it</a:t>
             </a:r>
           </a:p>
         </p:txBody>
@@ -3321,25 +3320,31 @@
           <a:p>
             <a:pPr lvl="1"/>
             <a:r>
-              <a:t>The profile is real but thin. The population that has done this job at this scale is smaller than the specification implies it is.</a:t>
+              <a:t>John Chang is mapping the engineering-leadership market and building the long list we work from.</a:t>
             </a:r>
           </a:p>
           <a:p>
             <a:pPr lvl="1"/>
             <a:r>
-              <a:t>Nearly all of it is employed, senior, and not looking. Every conversation opens as a favor, not as an application.</a:t>
+              <a:t>James Grant is assessing the strongest sitting leaders against the brief and shaping the shortlist.</a:t>
             </a:r>
           </a:p>
           <a:p>
             <a:pPr lvl="1"/>
             <a:r>
-              <a:t>Two adjacent pools are worth opening: operators one level down inside larger organizations, and this profile at companies going through a different kind of change.</a:t>
+              <a:t>Approaches are discreet; we describe candidates by their current seat, never by name, in anything that circulates.</a:t>
             </a:r>
           </a:p>
           <a:p>
             <a:pPr lvl="1"/>
             <a:r>
-              <a:t>Compensation is not the binding constraint we expected. Scope is.</a:t>
+              <a:t>We ask the same discretion of you, since most of the people we approach have not spoken to their employers.</a:t>
+            </a:r>
+          </a:p>
+          <a:p>
+            <a:pPr lvl="1"/>
+            <a:r>
+              <a:t>Jeffrey Patterson keeps the search moving day to day and is your single point of contact.</a:t>
             </a:r>
           </a:p>
         </p:txBody>
@@ -3383,7 +3388,7 @@
                   <a:srgbClr val="1E4D2B"/>
                 </a:solidFill>
               </a:rPr>
-              <a:t>How We Are Working It</a:t>
+              <a:t>Where we are today</a:t>
             </a:r>
           </a:p>
         </p:txBody>
@@ -3405,25 +3410,31 @@
           <a:p>
             <a:pPr lvl="1"/>
             <a:r>
-              <a:t>Approaches are made by a person, not by a firm. James Grant makes the first call at the senior end, because that is the call that gets returned.</a:t>
+              <a:t>The market map is well advanced and reaching into two adjacent sectors where the experience also sits.</a:t>
             </a:r>
           </a:p>
           <a:p>
             <a:pPr lvl="1"/>
             <a:r>
-              <a:t>John Chang holds the map and the record. Every approach, every response, every decline with its reason.</a:t>
+              <a:t>The specification is agreed and already in use to calibrate every name.</a:t>
             </a:r>
           </a:p>
           <a:p>
             <a:pPr lvl="1"/>
             <a:r>
-              <a:t>Nothing goes forward that we have not met twice. You should not be the second interview a candidate has had.</a:t>
+              <a:t>The first discreet approaches are underway, and early conversations are encouraging.</a:t>
             </a:r>
           </a:p>
           <a:p>
             <a:pPr lvl="1"/>
             <a:r>
-              <a:t>We keep the set-asides. What we put down and why is as much of the product as what we bring you.</a:t>
+              <a:t>Two names stand out so far, both described here by their current seat rather than by name.</a:t>
+            </a:r>
+          </a:p>
+          <a:p>
+            <a:pPr lvl="1"/>
+            <a:r>
+              <a:t>No slate yet: we are still widening the field, not narrowing it, which is right for this stage.</a:t>
             </a:r>
           </a:p>
         </p:txBody>
@@ -3467,7 +3478,7 @@
                   <a:srgbClr val="1E4D2B"/>
                 </a:solidFill>
               </a:rPr>
-              <a:t>What We Need From You</a:t>
+              <a:t>What comes next</a:t>
             </a:r>
           </a:p>
         </p:txBody>
@@ -3489,109 +3500,31 @@
           <a:p>
             <a:pPr lvl="1"/>
             <a:r>
-              <a:t>A calibration session on four to six anonymized profiles. These are samples, not candidates; nobody in the pack is someone you can hire.</a:t>
+              <a:t>Complete the market approaches over the coming weeks and let the field settle.</a:t>
             </a:r>
           </a:p>
           <a:p>
             <a:pPr lvl="1"/>
             <a:r>
-              <a:t>A decision on the adjacent pools above. In or out, decided once, so that we are not relitigating it at the slate.</a:t>
+              <a:t>Work the long list down into a shortlist we will stand behind.</a:t>
             </a:r>
           </a:p>
           <a:p>
             <a:pPr lvl="1"/>
             <a:r>
-              <a:t>Confirmation of everyone who holds a vote on this hire, including anyone who holds one informally.</a:t>
+              <a:t>Complete first references before anyone reaches your interview room.</a:t>
             </a:r>
           </a:p>
           <a:p>
             <a:pPr lvl="1"/>
             <a:r>
-              <a:t>Interview availability blocked now, ahead of the slate rather than after it.</a:t>
-            </a:r>
-          </a:p>
-        </p:txBody>
-      </p:sp>
-    </p:spTree>
-  </p:cSld>
-  <p:clrMapOvr>
-    <a:masterClrMapping/>
-  </p:clrMapOvr>
-</p:sld>
-</file>
-
-<file path=ppt/slides/slide6.xml><?xml version="1.0" encoding="utf-8"?>
-<p:sld xmlns:a="http://schemas.openxmlformats.org/drawingml/2006/main" xmlns:p="http://schemas.openxmlformats.org/presentationml/2006/main" xmlns:r="http://schemas.openxmlformats.org/officeDocument/2006/relationships">
-  <p:cSld>
-    <p:spTree>
-      <p:nvGrpSpPr>
-        <p:cNvPr id="1" name=""/>
-        <p:cNvGrpSpPr/>
-        <p:nvPr/>
-      </p:nvGrpSpPr>
-      <p:grpSpPr/>
-      <p:sp>
-        <p:nvSpPr>
-          <p:cNvPr id="2" name="Title 1"/>
-          <p:cNvSpPr>
-            <a:spLocks noGrp="1"/>
-          </p:cNvSpPr>
-          <p:nvPr>
-            <p:ph type="title"/>
-          </p:nvPr>
-        </p:nvSpPr>
-        <p:spPr/>
-        <p:txBody>
-          <a:bodyPr/>
-          <a:lstStyle/>
-          <a:p>
-            <a:r>
-              <a:rPr>
-                <a:solidFill>
-                  <a:srgbClr val="1E4D2B"/>
-                </a:solidFill>
-              </a:rPr>
-              <a:t>Next Steps</a:t>
-            </a:r>
-          </a:p>
-        </p:txBody>
-      </p:sp>
-      <p:sp>
-        <p:nvSpPr>
-          <p:cNvPr id="3" name="Content Placeholder 2"/>
-          <p:cNvSpPr>
-            <a:spLocks noGrp="1"/>
-          </p:cNvSpPr>
-          <p:nvPr>
-            <p:ph idx="1"/>
-          </p:nvPr>
-        </p:nvSpPr>
-        <p:spPr/>
-        <p:txBody>
-          <a:bodyPr/>
-          <a:lstStyle/>
+              <a:t>Bring a first slate to Michael Martin for discussion, with candidates ready to meet you.</a:t>
+            </a:r>
+          </a:p>
           <a:p>
             <a:pPr lvl="1"/>
             <a:r>
-              <a:t>James Grant runs the calibration session with you and your team.</a:t>
-            </a:r>
-          </a:p>
-          <a:p>
-            <a:pPr lvl="1"/>
-            <a:r>
-              <a:t>John Chang extends the map into the adjacent pools, should you open them.</a:t>
-            </a:r>
-          </a:p>
-          <a:p>
-            <a:pPr lvl="1"/>
-            <a:r>
-              <a:t>Jeffrey Patterson reissues the specification if calibration moves it, and it usually moves it.</a:t>
-            </a:r>
-          </a:p>
-          <a:p>
-            <a:pPr lvl="1"/>
-            <a:r>
-              <a:t>Written update weekly. James Grant calls if something cannot wait for the written one.</a:t>
+              <a:t>Hold the weekly rhythm of updates between now and then, so no one has to ask.</a:t>
             </a:r>
           </a:p>
         </p:txBody>

</xml_diff>